<commit_message>
Fill in university and supervisor on presentation title slide
</commit_message>
<xml_diff>
--- a/presentation/Documind_AI_Presentation.pptx
+++ b/presentation/Documind_AI_Presentation.pptx
@@ -3542,7 +3542,7 @@
                 </a:solidFill>
                 <a:latin typeface="Segoe UI"/>
               </a:rPr>
-              <a:t>Your University Name</a:t>
+              <a:t>Superior University</a:t>
             </a:r>
           </a:p>
         </p:txBody>
@@ -3581,7 +3581,7 @@
                 </a:solidFill>
                 <a:latin typeface="Segoe UI"/>
               </a:rPr>
-              <a:t>Department of Computer Science  |  Supervisor: Dr. [Supervisor Name]</a:t>
+              <a:t>Department of Computer Science  |  Supervisor: Alen Rafugodinov</a:t>
             </a:r>
           </a:p>
         </p:txBody>

</xml_diff>